<commit_message>
fix(pptx): write presProps/viewProps/tableStyles, master txStyles and presentation theme rel; add per-type decks
PowerPoint reported a repair prompt on the first real open of a generated deck. The
package lacked parts PowerPoint always writes. Also adds a .pptx next to every
word-verification .docx.

Co-Authored-By: Claude Sonnet 5.5 <noreply@anthropic.com>
</commit_message>
<xml_diff>
--- a/test-corpus/word-verification/all-types-deck.pptx
+++ b/test-corpus/word-verification/all-types-deck.pptx
@@ -126,6 +126,23 @@
   <p:sldLayoutIdLst>
     <p:sldLayoutId id="2147483649" r:id="rId1"/>
   </p:sldLayoutIdLst>
+  <p:txStyles>
+    <p:titleStyle>
+      <a:lvl1pPr algn="l">
+        <a:defRPr sz="4400"/>
+      </a:lvl1pPr>
+    </p:titleStyle>
+    <p:bodyStyle>
+      <a:lvl1pPr algn="l">
+        <a:defRPr sz="1800"/>
+      </a:lvl1pPr>
+    </p:bodyStyle>
+    <p:otherStyle>
+      <a:defPPr>
+        <a:defRPr lang="en-US"/>
+      </a:defPPr>
+    </p:otherStyle>
+  </p:txStyles>
 </p:sldMaster>
 </file>
 

</xml_diff>

<commit_message>
fix(pptx): emit routed edges as p:sp, not p:cxnSp, so PowerPoint stops asking to repair
A p:cxnSp carrying a:custGeom made PowerPoint offer to repair the file. Found by
bisecting the 62-slide deck (four slides, all with a polyline edge). Regenerates every
per-type deck and drops the temporary bisect decks.

Co-Authored-By: Claude Sonnet 5.5 <noreply@anthropic.com>
</commit_message>
<xml_diff>
--- a/test-corpus/word-verification/all-types-deck.pptx
+++ b/test-corpus/word-verification/all-types-deck.pptx
@@ -947,15 +947,12 @@
           </a:fontRef>
         </p:style>
       </p:cxnSp>
-      <p:cxnSp>
-        <p:nvCxnSpPr>
+      <p:sp>
+        <p:nvSpPr>
           <p:cNvPr id="18" name="C--A"/>
-          <p:cNvCxnSpPr>
-            <a:stCxn id="14" idx="0"/>
-            <a:endCxn id="12" idx="2"/>
-          </p:cNvCxnSpPr>
-          <p:nvPr/>
-        </p:nvCxnSpPr>
+          <p:cNvSpPr/>
+          <p:nvPr/>
+        </p:nvSpPr>
         <p:spPr>
           <a:xfrm>
             <a:off x="6327796" y="1774825"/>
@@ -1009,7 +1006,7 @@
             <a:schemeClr val="tx1"/>
           </a:fontRef>
         </p:style>
-      </p:cxnSp>
+      </p:sp>
       <p:cxnSp>
         <p:nvCxnSpPr>
           <p:cNvPr id="19" name="C--D"/>
@@ -2630,15 +2627,12 @@
           </a:p>
         </p:txBody>
       </p:sp>
-      <p:cxnSp>
-        <p:nvCxnSpPr>
+      <p:sp>
+        <p:nvSpPr>
           <p:cNvPr id="19" name="B--D"/>
-          <p:cNvCxnSpPr>
-            <a:stCxn id="13" idx="2"/>
-            <a:endCxn id="15" idx="0"/>
-          </p:cNvCxnSpPr>
-          <p:nvPr/>
-        </p:nvCxnSpPr>
+          <p:cNvSpPr/>
+          <p:nvPr/>
+        </p:nvSpPr>
         <p:spPr>
           <a:xfrm>
             <a:off x="5639154" y="3692912"/>
@@ -2692,7 +2686,7 @@
             <a:schemeClr val="tx1"/>
           </a:fontRef>
         </p:style>
-      </p:cxnSp>
+      </p:sp>
       <p:sp>
         <p:nvSpPr>
           <p:cNvPr id="20" name="EdgeLabel"/>
@@ -10178,15 +10172,12 @@
           </a:fontRef>
         </p:style>
       </p:cxnSp>
-      <p:cxnSp>
-        <p:nvCxnSpPr>
+      <p:sp>
+        <p:nvSpPr>
           <p:cNvPr id="22" name="D--B"/>
-          <p:cNvCxnSpPr>
-            <a:stCxn id="15" idx="1"/>
-            <a:endCxn id="13" idx="3"/>
-          </p:cNvCxnSpPr>
-          <p:nvPr/>
-        </p:nvCxnSpPr>
+          <p:cNvSpPr/>
+          <p:nvPr/>
+        </p:nvSpPr>
         <p:spPr>
           <a:xfrm>
             <a:off x="5902036" y="2545774"/>
@@ -10240,7 +10231,7 @@
             <a:schemeClr val="tx1"/>
           </a:fontRef>
         </p:style>
-      </p:cxnSp>
+      </p:sp>
       <p:cxnSp>
         <p:nvCxnSpPr>
           <p:cNvPr id="23" name="A--E"/>
@@ -67209,15 +67200,12 @@
           </a:fontRef>
         </p:style>
       </p:cxnSp>
-      <p:cxnSp>
-        <p:nvCxnSpPr>
+      <p:sp>
+        <p:nvSpPr>
           <p:cNvPr id="22" name="A1--B3"/>
-          <p:cNvCxnSpPr>
-            <a:stCxn id="12" idx="2"/>
-            <a:endCxn id="15" idx="0"/>
-          </p:cNvCxnSpPr>
-          <p:nvPr/>
-        </p:nvCxnSpPr>
+          <p:cNvSpPr/>
+          <p:nvPr/>
+        </p:nvSpPr>
         <p:spPr>
           <a:xfrm>
             <a:off x="5440866" y="1683834"/>
@@ -67265,7 +67253,7 @@
             <a:schemeClr val="tx1"/>
           </a:fontRef>
         </p:style>
-      </p:cxnSp>
+      </p:sp>
       <p:cxnSp>
         <p:nvCxnSpPr>
           <p:cNvPr id="23" name="A2--B1"/>
@@ -67386,15 +67374,12 @@
           </a:fontRef>
         </p:style>
       </p:cxnSp>
-      <p:cxnSp>
-        <p:nvCxnSpPr>
+      <p:sp>
+        <p:nvSpPr>
           <p:cNvPr id="26" name="A3--B2"/>
-          <p:cNvCxnSpPr>
-            <a:stCxn id="18" idx="0"/>
-            <a:endCxn id="14" idx="2"/>
-          </p:cNvCxnSpPr>
-          <p:nvPr/>
-        </p:nvCxnSpPr>
+          <p:cNvSpPr/>
+          <p:nvPr/>
+        </p:nvSpPr>
         <p:spPr>
           <a:xfrm>
             <a:off x="5440866" y="3452696"/>
@@ -67442,7 +67427,7 @@
             <a:schemeClr val="tx1"/>
           </a:fontRef>
         </p:style>
-      </p:cxnSp>
+      </p:sp>
       <p:cxnSp>
         <p:nvCxnSpPr>
           <p:cNvPr id="27" name="A3--B3"/>

</xml_diff>